<commit_message>
feat(service-discovery): Schemes Option B is the filter panel again; the last three persona figures land
- Option B returns to the reference's second frame: the Target Group panel
  on the left, more than one group tickable, the table on the right, with
  the same Offerings/Schemes & Services header as Option A. Only Option A
  carries the picture rail.
- Persons Engaged in Begging, Persons Affected by Substance Use and Victims
  of Atrocities now have their figures from the design file; Victims of
  Atrocities is no longer an icon.
- Recording, stills, deck copy, PPTX and PDF regenerated.
</commit_message>
<xml_diff>
--- a/docs/plans/MoSJE-Service-Discovery-Options.pptx
+++ b/docs/plans/MoSJE-Service-Discovery-Options.pptx
@@ -1392,7 +1392,7 @@
           <a:p>
             <a:r>
               <a:rPr lang="en-US" dirty="0"/>
-              <a:t>The reference layout with a table beneath the row of groups: what each scheme gives and who it is for, ten rows a page, no counts. This is for comparing and deciding. Press play: it is a real page being used, not an animation.</a:t>
+              <a:t>The reference layout with the filter panel: tick one or more groups, and the table on the right says what each scheme gives and who it is for, ten rows a page, no counts. This is for comparing and deciding. Press play: it is a real page being used, not an animation.</a:t>
             </a:r>
             <a:endParaRPr lang="en-US" dirty="0"/>
           </a:p>
@@ -3463,7 +3463,7 @@
                 <a:ea typeface="Noto Sans" pitchFamily="34" charset="-122"/>
                 <a:cs typeface="Noto Sans" pitchFamily="34" charset="-120"/>
               </a:rPr>
-              <a:t>B · Pictures of the Groups, with a Table</a:t>
+              <a:t>B · Filter Panel with a Table</a:t>
             </a:r>
             <a:endParaRPr lang="en-US" sz="1500" dirty="0"/>
           </a:p>
@@ -3502,7 +3502,7 @@
                 <a:ea typeface="Noto Sans" pitchFamily="34" charset="-122"/>
                 <a:cs typeface="Noto Sans" pitchFamily="34" charset="-120"/>
               </a:rPr>
-              <a:t>The same row, then a table. For comparing.</a:t>
+              <a:t>Tick groups on the left, table on the right. For comparing.</a:t>
             </a:r>
             <a:endParaRPr lang="en-US" sz="1200" dirty="0"/>
           </a:p>
@@ -8333,7 +8333,7 @@
                 <a:ea typeface="Noto Sans" pitchFamily="34" charset="-122"/>
                 <a:cs typeface="Noto Sans" pitchFamily="34" charset="-120"/>
               </a:rPr>
-              <a:t>Pictures of the Groups, with a Table</a:t>
+              <a:t>Filter Panel with a Table</a:t>
             </a:r>
             <a:endParaRPr lang="en-US" sz="1400" dirty="0"/>
           </a:p>
@@ -8490,7 +8490,7 @@
                 <a:ea typeface="Noto Sans" pitchFamily="34" charset="-122"/>
                 <a:cs typeface="Noto Sans" pitchFamily="34" charset="-120"/>
               </a:rPr>
-              <a:t>The same row of groups, then a table that says who each scheme is for. For comparing.</a:t>
+              <a:t>Tick one or more groups on the left; the table says who each scheme is for. For comparing.</a:t>
             </a:r>
             <a:endParaRPr lang="en-US" sz="1200" dirty="0"/>
           </a:p>
@@ -9370,7 +9370,7 @@
                 <a:ea typeface="Noto Sans" pitchFamily="34" charset="-122"/>
                 <a:cs typeface="Noto Sans" pitchFamily="34" charset="-120"/>
               </a:rPr>
-              <a:t>PICTURES OF THE GROUPS, WITH A TABLE</a:t>
+              <a:t>FILTER PANEL WITH A TABLE</a:t>
             </a:r>
             <a:endParaRPr lang="en-US" sz="950" dirty="0"/>
           </a:p>
@@ -9575,7 +9575,7 @@
                 <a:ea typeface="Noto Sans" pitchFamily="34" charset="-122"/>
                 <a:cs typeface="Noto Sans" pitchFamily="34" charset="-120"/>
               </a:rPr>
-              <a:t>▶  Recorded: Other Backward Classes with Scholarships, then Loans added, then one filter removed.</a:t>
+              <a:t>▶  Recorded: Other Backward Classes ticked, then Students added, then one removed, then Reset.</a:t>
             </a:r>
             <a:endParaRPr lang="en-US" sz="850" dirty="0"/>
           </a:p>
@@ -9629,7 +9629,7 @@
         <p:spPr>
           <a:xfrm>
             <a:off x="7680960" y="2057400"/>
-            <a:ext cx="3779215" cy="438912"/>
+            <a:ext cx="3779215" cy="630936"/>
           </a:xfrm>
           <a:prstGeom prst="rect">
             <a:avLst/>
@@ -9656,7 +9656,7 @@
                 <a:ea typeface="Noto Sans" pitchFamily="34" charset="-122"/>
                 <a:cs typeface="Noto Sans" pitchFamily="34" charset="-120"/>
               </a:rPr>
-              <a:t>The same row of groups, with a table beneath instead of cards.</a:t>
+              <a:t>A panel of the groups on the left, where more than one can be ticked, and a table on the right.</a:t>
             </a:r>
             <a:endParaRPr lang="en-US" sz="1200" dirty="0"/>
           </a:p>
@@ -9670,7 +9670,7 @@
         </p:nvSpPr>
         <p:spPr>
           <a:xfrm>
-            <a:off x="7680960" y="2697480"/>
+            <a:off x="7680960" y="2889504"/>
             <a:ext cx="3779215" cy="201168"/>
           </a:xfrm>
           <a:prstGeom prst="rect">
@@ -9709,7 +9709,7 @@
         </p:nvSpPr>
         <p:spPr>
           <a:xfrm>
-            <a:off x="7680960" y="3035808"/>
+            <a:off x="7680960" y="3227832"/>
             <a:ext cx="54864" cy="54864"/>
           </a:xfrm>
           <a:prstGeom prst="rect">
@@ -9734,7 +9734,7 @@
         </p:nvSpPr>
         <p:spPr>
           <a:xfrm>
-            <a:off x="7863840" y="2971800"/>
+            <a:off x="7863840" y="3163824"/>
             <a:ext cx="3596335" cy="420624"/>
           </a:xfrm>
           <a:prstGeom prst="rect">
@@ -9762,7 +9762,7 @@
                 <a:ea typeface="Noto Sans" pitchFamily="34" charset="-122"/>
                 <a:cs typeface="Noto Sans" pitchFamily="34" charset="-120"/>
               </a:rPr>
-              <a:t>Pick a group from the row; it scrolls sideways</a:t>
+              <a:t>Tick one or more groups; the chosen ones show above the table</a:t>
             </a:r>
             <a:endParaRPr lang="en-US" sz="1200" dirty="0"/>
           </a:p>
@@ -9776,7 +9776,7 @@
         </p:nvSpPr>
         <p:spPr>
           <a:xfrm>
-            <a:off x="7680960" y="3529584"/>
+            <a:off x="7680960" y="3721608"/>
             <a:ext cx="54864" cy="54864"/>
           </a:xfrm>
           <a:prstGeom prst="rect">
@@ -9801,7 +9801,7 @@
         </p:nvSpPr>
         <p:spPr>
           <a:xfrm>
-            <a:off x="7863840" y="3465576"/>
+            <a:off x="7863840" y="3657600"/>
             <a:ext cx="3596335" cy="420624"/>
           </a:xfrm>
           <a:prstGeom prst="rect">
@@ -9843,7 +9843,7 @@
         </p:nvSpPr>
         <p:spPr>
           <a:xfrm>
-            <a:off x="7680960" y="4023360"/>
+            <a:off x="7680960" y="4215384"/>
             <a:ext cx="54864" cy="54864"/>
           </a:xfrm>
           <a:prstGeom prst="rect">
@@ -9868,7 +9868,7 @@
         </p:nvSpPr>
         <p:spPr>
           <a:xfrm>
-            <a:off x="7863840" y="3959352"/>
+            <a:off x="7863840" y="4151376"/>
             <a:ext cx="3596335" cy="420624"/>
           </a:xfrm>
           <a:prstGeom prst="rect">
@@ -9910,7 +9910,7 @@
         </p:nvSpPr>
         <p:spPr>
           <a:xfrm>
-            <a:off x="7680960" y="4654296"/>
+            <a:off x="7680960" y="4846320"/>
             <a:ext cx="3779215" cy="201168"/>
           </a:xfrm>
           <a:prstGeom prst="rect">
@@ -9949,7 +9949,7 @@
         </p:nvSpPr>
         <p:spPr>
           <a:xfrm>
-            <a:off x="7680960" y="4992624"/>
+            <a:off x="7680960" y="5184648"/>
             <a:ext cx="54864" cy="54864"/>
           </a:xfrm>
           <a:prstGeom prst="rect">
@@ -9974,7 +9974,7 @@
         </p:nvSpPr>
         <p:spPr>
           <a:xfrm>
-            <a:off x="7863840" y="4928616"/>
+            <a:off x="7863840" y="5120640"/>
             <a:ext cx="3596335" cy="228600"/>
           </a:xfrm>
           <a:prstGeom prst="rect">
@@ -10002,7 +10002,7 @@
                 <a:ea typeface="Noto Sans" pitchFamily="34" charset="-122"/>
                 <a:cs typeface="Noto Sans" pitchFamily="34" charset="-120"/>
               </a:rPr>
-              <a:t>Two schemes can be read side by side</a:t>
+              <a:t>Two groups can be compared in one list</a:t>
             </a:r>
             <a:endParaRPr lang="en-US" sz="1200" dirty="0"/>
           </a:p>
@@ -10016,7 +10016,7 @@
         </p:nvSpPr>
         <p:spPr>
           <a:xfrm>
-            <a:off x="7680960" y="5294376"/>
+            <a:off x="7680960" y="5486400"/>
             <a:ext cx="54864" cy="54864"/>
           </a:xfrm>
           <a:prstGeom prst="rect">
@@ -10041,7 +10041,7 @@
         </p:nvSpPr>
         <p:spPr>
           <a:xfrm>
-            <a:off x="7863840" y="5230368"/>
+            <a:off x="7863840" y="5422392"/>
             <a:ext cx="3596335" cy="420624"/>
           </a:xfrm>
           <a:prstGeom prst="rect">
@@ -10069,7 +10069,7 @@
                 <a:ea typeface="Noto Sans" pitchFamily="34" charset="-122"/>
                 <a:cs typeface="Noto Sans" pitchFamily="34" charset="-120"/>
               </a:rPr>
-              <a:t>The table has room to say who each scheme is for</a:t>
+              <a:t>A group that would leave nothing is greyed, never counted</a:t>
             </a:r>
             <a:endParaRPr lang="en-US" sz="1200" dirty="0"/>
           </a:p>

</xml_diff>